<commit_message>
Deck with the rendered diagrams
</commit_message>
<xml_diff>
--- a/presentation/QueryMend_slides.pptx
+++ b/presentation/QueryMend_slides.pptx
@@ -8868,113 +8868,33 @@
           </a:p>
         </p:txBody>
       </p:sp>
-      <p:sp>
-        <p:nvSpPr>
-          <p:cNvPr id="8" name="Rounded Rectangle 7"/>
-          <p:cNvSpPr/>
-          <p:nvPr/>
-        </p:nvSpPr>
-        <p:spPr>
-          <a:xfrm>
-            <a:off x="640080" y="1691640"/>
-            <a:ext cx="5120640" cy="4526280"/>
-          </a:xfrm>
-          <a:prstGeom prst="roundRect">
-            <a:avLst>
-              <a:gd name="adj" fmla="val 2424"/>
-            </a:avLst>
-          </a:prstGeom>
-          <a:solidFill>
-            <a:srgbClr val="F8FAFC"/>
-          </a:solidFill>
-          <a:ln w="12700">
-            <a:solidFill>
-              <a:srgbClr val="64748B"/>
-            </a:solidFill>
-            <a:prstDash val="dash"/>
-          </a:ln>
-          <a:effectLst/>
-        </p:spPr>
-        <p:style>
-          <a:lnRef idx="1">
-            <a:schemeClr val="accent1"/>
-          </a:lnRef>
-          <a:fillRef idx="3">
-            <a:schemeClr val="accent1"/>
-          </a:fillRef>
-          <a:effectRef idx="2">
-            <a:schemeClr val="accent1"/>
-          </a:effectRef>
-          <a:fontRef idx="minor">
-            <a:schemeClr val="lt1"/>
-          </a:fontRef>
-        </p:style>
-        <p:txBody>
-          <a:bodyPr rtlCol="0" anchor="ctr"/>
-          <a:lstStyle/>
-          <a:p>
-            <a:pPr algn="ctr"/>
-          </a:p>
-        </p:txBody>
-      </p:sp>
-      <p:sp>
-        <p:nvSpPr>
-          <p:cNvPr id="9" name="TextBox 8"/>
-          <p:cNvSpPr txBox="1"/>
-          <p:nvPr/>
-        </p:nvSpPr>
-        <p:spPr>
-          <a:xfrm>
-            <a:off x="640080" y="1691640"/>
-            <a:ext cx="5120640" cy="4526280"/>
-          </a:xfrm>
-          <a:prstGeom prst="rect">
-            <a:avLst/>
-          </a:prstGeom>
-          <a:noFill/>
-        </p:spPr>
-        <p:txBody>
-          <a:bodyPr wrap="square" anchor="ctr" lIns="0" rIns="0" tIns="0" bIns="0">
-            <a:spAutoFit/>
-          </a:bodyPr>
-          <a:lstStyle/>
-          <a:p>
-            <a:pPr algn="ctr">
-              <a:lnSpc>
-                <a:spcPct val="110000"/>
-              </a:lnSpc>
-            </a:pPr>
-            <a:r>
-              <a:rPr sz="1600">
-                <a:solidFill>
-                  <a:srgbClr val="64748B"/>
-                </a:solidFill>
-                <a:latin typeface="Segoe UI"/>
-              </a:rPr>
-              <a:t>Diagram goes here</a:t>
-            </a:r>
-          </a:p>
-          <a:p>
-            <a:pPr algn="ctr">
-              <a:lnSpc>
-                <a:spcPct val="110000"/>
-              </a:lnSpc>
-            </a:pPr>
-            <a:r>
-              <a:rPr sz="1300">
-                <a:solidFill>
-                  <a:srgbClr val="64748B"/>
-                </a:solidFill>
-                <a:latin typeface="Consolas"/>
-              </a:rPr>
-              <a:t>report/diagrams/drawio/01_pba1_agent.png</a:t>
-            </a:r>
-          </a:p>
-        </p:txBody>
-      </p:sp>
-      <p:sp>
-        <p:nvSpPr>
-          <p:cNvPr id="10" name="Rounded Rectangle 9"/>
+      <p:pic>
+        <p:nvPicPr>
+          <p:cNvPr id="8" name="Picture 7" descr="01_pba1_agent.png"/>
+          <p:cNvPicPr>
+            <a:picLocks noChangeAspect="1"/>
+          </p:cNvPicPr>
+          <p:nvPr/>
+        </p:nvPicPr>
+        <p:blipFill>
+          <a:blip r:embed="rId2"/>
+          <a:stretch>
+            <a:fillRect/>
+          </a:stretch>
+        </p:blipFill>
+        <p:spPr>
+          <a:xfrm>
+            <a:off x="829491" y="1691640"/>
+            <a:ext cx="4741817" cy="4526280"/>
+          </a:xfrm>
+          <a:prstGeom prst="rect">
+            <a:avLst/>
+          </a:prstGeom>
+        </p:spPr>
+      </p:pic>
+      <p:sp>
+        <p:nvSpPr>
+          <p:cNvPr id="9" name="Rounded Rectangle 8"/>
           <p:cNvSpPr/>
           <p:nvPr/>
         </p:nvSpPr>
@@ -9022,7 +8942,7 @@
       </p:sp>
       <p:sp>
         <p:nvSpPr>
-          <p:cNvPr id="11" name="Rectangle 10"/>
+          <p:cNvPr id="10" name="Rectangle 9"/>
           <p:cNvSpPr/>
           <p:nvPr/>
         </p:nvSpPr>
@@ -9066,7 +8986,7 @@
       </p:sp>
       <p:sp>
         <p:nvSpPr>
-          <p:cNvPr id="12" name="TextBox 11"/>
+          <p:cNvPr id="11" name="TextBox 10"/>
           <p:cNvSpPr txBox="1"/>
           <p:nvPr/>
         </p:nvSpPr>
@@ -9105,7 +9025,7 @@
       </p:sp>
       <p:sp>
         <p:nvSpPr>
-          <p:cNvPr id="13" name="TextBox 12"/>
+          <p:cNvPr id="12" name="TextBox 11"/>
           <p:cNvSpPr txBox="1"/>
           <p:nvPr/>
         </p:nvSpPr>
@@ -9144,7 +9064,7 @@
       </p:sp>
       <p:sp>
         <p:nvSpPr>
-          <p:cNvPr id="14" name="TextBox 13"/>
+          <p:cNvPr id="13" name="TextBox 12"/>
           <p:cNvSpPr txBox="1"/>
           <p:nvPr/>
         </p:nvSpPr>
@@ -9183,7 +9103,7 @@
       </p:sp>
       <p:sp>
         <p:nvSpPr>
-          <p:cNvPr id="15" name="Rounded Rectangle 14"/>
+          <p:cNvPr id="14" name="Rounded Rectangle 13"/>
           <p:cNvSpPr/>
           <p:nvPr/>
         </p:nvSpPr>
@@ -9231,7 +9151,7 @@
       </p:sp>
       <p:sp>
         <p:nvSpPr>
-          <p:cNvPr id="16" name="Rectangle 15"/>
+          <p:cNvPr id="15" name="Rectangle 14"/>
           <p:cNvSpPr/>
           <p:nvPr/>
         </p:nvSpPr>
@@ -9275,7 +9195,7 @@
       </p:sp>
       <p:sp>
         <p:nvSpPr>
-          <p:cNvPr id="17" name="TextBox 16"/>
+          <p:cNvPr id="16" name="TextBox 15"/>
           <p:cNvSpPr txBox="1"/>
           <p:nvPr/>
         </p:nvSpPr>
@@ -9314,7 +9234,7 @@
       </p:sp>
       <p:sp>
         <p:nvSpPr>
-          <p:cNvPr id="18" name="TextBox 17"/>
+          <p:cNvPr id="17" name="TextBox 16"/>
           <p:cNvSpPr txBox="1"/>
           <p:nvPr/>
         </p:nvSpPr>
@@ -9353,7 +9273,7 @@
       </p:sp>
       <p:sp>
         <p:nvSpPr>
-          <p:cNvPr id="19" name="TextBox 18"/>
+          <p:cNvPr id="18" name="TextBox 17"/>
           <p:cNvSpPr txBox="1"/>
           <p:nvPr/>
         </p:nvSpPr>
@@ -9392,7 +9312,7 @@
       </p:sp>
       <p:sp>
         <p:nvSpPr>
-          <p:cNvPr id="20" name="TextBox 19"/>
+          <p:cNvPr id="19" name="TextBox 18"/>
           <p:cNvSpPr txBox="1"/>
           <p:nvPr/>
         </p:nvSpPr>
@@ -9440,7 +9360,7 @@
       </p:sp>
       <p:sp>
         <p:nvSpPr>
-          <p:cNvPr id="21" name="TextBox 20"/>
+          <p:cNvPr id="20" name="TextBox 19"/>
           <p:cNvSpPr txBox="1"/>
           <p:nvPr/>
         </p:nvSpPr>
@@ -9479,7 +9399,7 @@
       </p:sp>
       <p:sp>
         <p:nvSpPr>
-          <p:cNvPr id="22" name="TextBox 21"/>
+          <p:cNvPr id="21" name="TextBox 20"/>
           <p:cNvSpPr txBox="1"/>
           <p:nvPr/>
         </p:nvSpPr>
@@ -9796,113 +9716,33 @@
           </a:p>
         </p:txBody>
       </p:sp>
-      <p:sp>
-        <p:nvSpPr>
-          <p:cNvPr id="8" name="Rounded Rectangle 7"/>
-          <p:cNvSpPr/>
-          <p:nvPr/>
-        </p:nvSpPr>
-        <p:spPr>
-          <a:xfrm>
-            <a:off x="640080" y="1600200"/>
-            <a:ext cx="10908792" cy="3291840"/>
-          </a:xfrm>
-          <a:prstGeom prst="roundRect">
-            <a:avLst>
-              <a:gd name="adj" fmla="val 3333"/>
-            </a:avLst>
-          </a:prstGeom>
-          <a:solidFill>
-            <a:srgbClr val="F8FAFC"/>
-          </a:solidFill>
-          <a:ln w="12700">
-            <a:solidFill>
-              <a:srgbClr val="64748B"/>
-            </a:solidFill>
-            <a:prstDash val="dash"/>
-          </a:ln>
-          <a:effectLst/>
-        </p:spPr>
-        <p:style>
-          <a:lnRef idx="1">
-            <a:schemeClr val="accent1"/>
-          </a:lnRef>
-          <a:fillRef idx="3">
-            <a:schemeClr val="accent1"/>
-          </a:fillRef>
-          <a:effectRef idx="2">
-            <a:schemeClr val="accent1"/>
-          </a:effectRef>
-          <a:fontRef idx="minor">
-            <a:schemeClr val="lt1"/>
-          </a:fontRef>
-        </p:style>
-        <p:txBody>
-          <a:bodyPr rtlCol="0" anchor="ctr"/>
-          <a:lstStyle/>
-          <a:p>
-            <a:pPr algn="ctr"/>
-          </a:p>
-        </p:txBody>
-      </p:sp>
-      <p:sp>
-        <p:nvSpPr>
-          <p:cNvPr id="9" name="TextBox 8"/>
-          <p:cNvSpPr txBox="1"/>
-          <p:nvPr/>
-        </p:nvSpPr>
-        <p:spPr>
-          <a:xfrm>
-            <a:off x="640080" y="1600200"/>
-            <a:ext cx="10908792" cy="3291840"/>
-          </a:xfrm>
-          <a:prstGeom prst="rect">
-            <a:avLst/>
-          </a:prstGeom>
-          <a:noFill/>
-        </p:spPr>
-        <p:txBody>
-          <a:bodyPr wrap="square" anchor="ctr" lIns="0" rIns="0" tIns="0" bIns="0">
-            <a:spAutoFit/>
-          </a:bodyPr>
-          <a:lstStyle/>
-          <a:p>
-            <a:pPr algn="ctr">
-              <a:lnSpc>
-                <a:spcPct val="110000"/>
-              </a:lnSpc>
-            </a:pPr>
-            <a:r>
-              <a:rPr sz="1600">
-                <a:solidFill>
-                  <a:srgbClr val="64748B"/>
-                </a:solidFill>
-                <a:latin typeface="Segoe UI"/>
-              </a:rPr>
-              <a:t>Diagram goes here</a:t>
-            </a:r>
-          </a:p>
-          <a:p>
-            <a:pPr algn="ctr">
-              <a:lnSpc>
-                <a:spcPct val="110000"/>
-              </a:lnSpc>
-            </a:pPr>
-            <a:r>
-              <a:rPr sz="1300">
-                <a:solidFill>
-                  <a:srgbClr val="64748B"/>
-                </a:solidFill>
-                <a:latin typeface="Consolas"/>
-              </a:rPr>
-              <a:t>report/diagrams/drawio/02_pba2_team.png</a:t>
-            </a:r>
-          </a:p>
-        </p:txBody>
-      </p:sp>
-      <p:sp>
-        <p:nvSpPr>
-          <p:cNvPr id="10" name="Rounded Rectangle 9"/>
+      <p:pic>
+        <p:nvPicPr>
+          <p:cNvPr id="8" name="Picture 7" descr="02_pba2_team.png"/>
+          <p:cNvPicPr>
+            <a:picLocks noChangeAspect="1"/>
+          </p:cNvPicPr>
+          <p:nvPr/>
+        </p:nvPicPr>
+        <p:blipFill>
+          <a:blip r:embed="rId2"/>
+          <a:stretch>
+            <a:fillRect/>
+          </a:stretch>
+        </p:blipFill>
+        <p:spPr>
+          <a:xfrm>
+            <a:off x="1465325" y="1600200"/>
+            <a:ext cx="9258300" cy="3291840"/>
+          </a:xfrm>
+          <a:prstGeom prst="rect">
+            <a:avLst/>
+          </a:prstGeom>
+        </p:spPr>
+      </p:pic>
+      <p:sp>
+        <p:nvSpPr>
+          <p:cNvPr id="9" name="Rounded Rectangle 8"/>
           <p:cNvSpPr/>
           <p:nvPr/>
         </p:nvSpPr>
@@ -9948,7 +9788,7 @@
       </p:sp>
       <p:sp>
         <p:nvSpPr>
-          <p:cNvPr id="11" name="Rectangle 10"/>
+          <p:cNvPr id="10" name="Rectangle 9"/>
           <p:cNvSpPr/>
           <p:nvPr/>
         </p:nvSpPr>
@@ -9992,7 +9832,7 @@
       </p:sp>
       <p:sp>
         <p:nvSpPr>
-          <p:cNvPr id="12" name="TextBox 11"/>
+          <p:cNvPr id="11" name="TextBox 10"/>
           <p:cNvSpPr txBox="1"/>
           <p:nvPr/>
         </p:nvSpPr>
@@ -10031,7 +9871,7 @@
       </p:sp>
       <p:sp>
         <p:nvSpPr>
-          <p:cNvPr id="13" name="TextBox 12"/>
+          <p:cNvPr id="12" name="TextBox 11"/>
           <p:cNvSpPr txBox="1"/>
           <p:nvPr/>
         </p:nvSpPr>
@@ -10070,7 +9910,7 @@
       </p:sp>
       <p:sp>
         <p:nvSpPr>
-          <p:cNvPr id="14" name="Rounded Rectangle 13"/>
+          <p:cNvPr id="13" name="Rounded Rectangle 12"/>
           <p:cNvSpPr/>
           <p:nvPr/>
         </p:nvSpPr>
@@ -10116,7 +9956,7 @@
       </p:sp>
       <p:sp>
         <p:nvSpPr>
-          <p:cNvPr id="15" name="Rectangle 14"/>
+          <p:cNvPr id="14" name="Rectangle 13"/>
           <p:cNvSpPr/>
           <p:nvPr/>
         </p:nvSpPr>
@@ -10160,7 +10000,7 @@
       </p:sp>
       <p:sp>
         <p:nvSpPr>
-          <p:cNvPr id="16" name="TextBox 15"/>
+          <p:cNvPr id="15" name="TextBox 14"/>
           <p:cNvSpPr txBox="1"/>
           <p:nvPr/>
         </p:nvSpPr>
@@ -10199,7 +10039,7 @@
       </p:sp>
       <p:sp>
         <p:nvSpPr>
-          <p:cNvPr id="17" name="TextBox 16"/>
+          <p:cNvPr id="16" name="TextBox 15"/>
           <p:cNvSpPr txBox="1"/>
           <p:nvPr/>
         </p:nvSpPr>
@@ -10238,7 +10078,7 @@
       </p:sp>
       <p:sp>
         <p:nvSpPr>
-          <p:cNvPr id="18" name="Rounded Rectangle 17"/>
+          <p:cNvPr id="17" name="Rounded Rectangle 16"/>
           <p:cNvSpPr/>
           <p:nvPr/>
         </p:nvSpPr>
@@ -10284,7 +10124,7 @@
       </p:sp>
       <p:sp>
         <p:nvSpPr>
-          <p:cNvPr id="19" name="Rectangle 18"/>
+          <p:cNvPr id="18" name="Rectangle 17"/>
           <p:cNvSpPr/>
           <p:nvPr/>
         </p:nvSpPr>
@@ -10328,7 +10168,7 @@
       </p:sp>
       <p:sp>
         <p:nvSpPr>
-          <p:cNvPr id="20" name="TextBox 19"/>
+          <p:cNvPr id="19" name="TextBox 18"/>
           <p:cNvSpPr txBox="1"/>
           <p:nvPr/>
         </p:nvSpPr>
@@ -10367,7 +10207,7 @@
       </p:sp>
       <p:sp>
         <p:nvSpPr>
-          <p:cNvPr id="21" name="TextBox 20"/>
+          <p:cNvPr id="20" name="TextBox 19"/>
           <p:cNvSpPr txBox="1"/>
           <p:nvPr/>
         </p:nvSpPr>
@@ -10406,7 +10246,7 @@
       </p:sp>
       <p:sp>
         <p:nvSpPr>
-          <p:cNvPr id="22" name="TextBox 21"/>
+          <p:cNvPr id="21" name="TextBox 20"/>
           <p:cNvSpPr txBox="1"/>
           <p:nvPr/>
         </p:nvSpPr>
@@ -10445,7 +10285,7 @@
       </p:sp>
       <p:sp>
         <p:nvSpPr>
-          <p:cNvPr id="23" name="TextBox 22"/>
+          <p:cNvPr id="22" name="TextBox 21"/>
           <p:cNvSpPr txBox="1"/>
           <p:nvPr/>
         </p:nvSpPr>
@@ -10762,113 +10602,33 @@
           </a:p>
         </p:txBody>
       </p:sp>
-      <p:sp>
-        <p:nvSpPr>
-          <p:cNvPr id="8" name="Rounded Rectangle 7"/>
-          <p:cNvSpPr/>
-          <p:nvPr/>
-        </p:nvSpPr>
-        <p:spPr>
-          <a:xfrm>
-            <a:off x="640080" y="1645920"/>
-            <a:ext cx="6766560" cy="4572000"/>
-          </a:xfrm>
-          <a:prstGeom prst="roundRect">
-            <a:avLst>
-              <a:gd name="adj" fmla="val 2400"/>
-            </a:avLst>
-          </a:prstGeom>
-          <a:solidFill>
-            <a:srgbClr val="F8FAFC"/>
-          </a:solidFill>
-          <a:ln w="12700">
-            <a:solidFill>
-              <a:srgbClr val="64748B"/>
-            </a:solidFill>
-            <a:prstDash val="dash"/>
-          </a:ln>
-          <a:effectLst/>
-        </p:spPr>
-        <p:style>
-          <a:lnRef idx="1">
-            <a:schemeClr val="accent1"/>
-          </a:lnRef>
-          <a:fillRef idx="3">
-            <a:schemeClr val="accent1"/>
-          </a:fillRef>
-          <a:effectRef idx="2">
-            <a:schemeClr val="accent1"/>
-          </a:effectRef>
-          <a:fontRef idx="minor">
-            <a:schemeClr val="lt1"/>
-          </a:fontRef>
-        </p:style>
-        <p:txBody>
-          <a:bodyPr rtlCol="0" anchor="ctr"/>
-          <a:lstStyle/>
-          <a:p>
-            <a:pPr algn="ctr"/>
-          </a:p>
-        </p:txBody>
-      </p:sp>
-      <p:sp>
-        <p:nvSpPr>
-          <p:cNvPr id="9" name="TextBox 8"/>
-          <p:cNvSpPr txBox="1"/>
-          <p:nvPr/>
-        </p:nvSpPr>
-        <p:spPr>
-          <a:xfrm>
-            <a:off x="640080" y="1645920"/>
-            <a:ext cx="6766560" cy="4572000"/>
-          </a:xfrm>
-          <a:prstGeom prst="rect">
-            <a:avLst/>
-          </a:prstGeom>
-          <a:noFill/>
-        </p:spPr>
-        <p:txBody>
-          <a:bodyPr wrap="square" anchor="ctr" lIns="0" rIns="0" tIns="0" bIns="0">
-            <a:spAutoFit/>
-          </a:bodyPr>
-          <a:lstStyle/>
-          <a:p>
-            <a:pPr algn="ctr">
-              <a:lnSpc>
-                <a:spcPct val="110000"/>
-              </a:lnSpc>
-            </a:pPr>
-            <a:r>
-              <a:rPr sz="1600">
-                <a:solidFill>
-                  <a:srgbClr val="64748B"/>
-                </a:solidFill>
-                <a:latin typeface="Segoe UI"/>
-              </a:rPr>
-              <a:t>Diagram goes here</a:t>
-            </a:r>
-          </a:p>
-          <a:p>
-            <a:pPr algn="ctr">
-              <a:lnSpc>
-                <a:spcPct val="110000"/>
-              </a:lnSpc>
-            </a:pPr>
-            <a:r>
-              <a:rPr sz="1300">
-                <a:solidFill>
-                  <a:srgbClr val="64748B"/>
-                </a:solidFill>
-                <a:latin typeface="Consolas"/>
-              </a:rPr>
-              <a:t>report/diagrams/drawio/05_one_recovery.png</a:t>
-            </a:r>
-          </a:p>
-        </p:txBody>
-      </p:sp>
-      <p:sp>
-        <p:nvSpPr>
-          <p:cNvPr id="10" name="Rounded Rectangle 9"/>
+      <p:pic>
+        <p:nvPicPr>
+          <p:cNvPr id="8" name="Picture 7" descr="05_one_recovery.png"/>
+          <p:cNvPicPr>
+            <a:picLocks noChangeAspect="1"/>
+          </p:cNvPicPr>
+          <p:nvPr/>
+        </p:nvPicPr>
+        <p:blipFill>
+          <a:blip r:embed="rId2"/>
+          <a:stretch>
+            <a:fillRect/>
+          </a:stretch>
+        </p:blipFill>
+        <p:spPr>
+          <a:xfrm>
+            <a:off x="848360" y="1645920"/>
+            <a:ext cx="6350000" cy="4572000"/>
+          </a:xfrm>
+          <a:prstGeom prst="rect">
+            <a:avLst/>
+          </a:prstGeom>
+        </p:spPr>
+      </p:pic>
+      <p:sp>
+        <p:nvSpPr>
+          <p:cNvPr id="9" name="Rounded Rectangle 8"/>
           <p:cNvSpPr/>
           <p:nvPr/>
         </p:nvSpPr>
@@ -10914,7 +10674,7 @@
       </p:sp>
       <p:sp>
         <p:nvSpPr>
-          <p:cNvPr id="11" name="TextBox 10"/>
+          <p:cNvPr id="10" name="TextBox 9"/>
           <p:cNvSpPr txBox="1"/>
           <p:nvPr/>
         </p:nvSpPr>
@@ -10953,7 +10713,7 @@
       </p:sp>
       <p:sp>
         <p:nvSpPr>
-          <p:cNvPr id="12" name="TextBox 11"/>
+          <p:cNvPr id="11" name="TextBox 10"/>
           <p:cNvSpPr txBox="1"/>
           <p:nvPr/>
         </p:nvSpPr>
@@ -10992,7 +10752,7 @@
       </p:sp>
       <p:sp>
         <p:nvSpPr>
-          <p:cNvPr id="13" name="TextBox 12"/>
+          <p:cNvPr id="12" name="TextBox 11"/>
           <p:cNvSpPr txBox="1"/>
           <p:nvPr/>
         </p:nvSpPr>
@@ -11031,7 +10791,7 @@
       </p:sp>
       <p:sp>
         <p:nvSpPr>
-          <p:cNvPr id="14" name="Rounded Rectangle 13"/>
+          <p:cNvPr id="13" name="Rounded Rectangle 12"/>
           <p:cNvSpPr/>
           <p:nvPr/>
         </p:nvSpPr>
@@ -11077,7 +10837,7 @@
       </p:sp>
       <p:sp>
         <p:nvSpPr>
-          <p:cNvPr id="15" name="TextBox 14"/>
+          <p:cNvPr id="14" name="TextBox 13"/>
           <p:cNvSpPr txBox="1"/>
           <p:nvPr/>
         </p:nvSpPr>
@@ -11116,7 +10876,7 @@
       </p:sp>
       <p:sp>
         <p:nvSpPr>
-          <p:cNvPr id="16" name="TextBox 15"/>
+          <p:cNvPr id="15" name="TextBox 14"/>
           <p:cNvSpPr txBox="1"/>
           <p:nvPr/>
         </p:nvSpPr>
@@ -11155,7 +10915,7 @@
       </p:sp>
       <p:sp>
         <p:nvSpPr>
-          <p:cNvPr id="17" name="TextBox 16"/>
+          <p:cNvPr id="16" name="TextBox 15"/>
           <p:cNvSpPr txBox="1"/>
           <p:nvPr/>
         </p:nvSpPr>
@@ -11194,7 +10954,7 @@
       </p:sp>
       <p:sp>
         <p:nvSpPr>
-          <p:cNvPr id="18" name="Rounded Rectangle 17"/>
+          <p:cNvPr id="17" name="Rounded Rectangle 16"/>
           <p:cNvSpPr/>
           <p:nvPr/>
         </p:nvSpPr>
@@ -11240,7 +11000,7 @@
       </p:sp>
       <p:sp>
         <p:nvSpPr>
-          <p:cNvPr id="19" name="TextBox 18"/>
+          <p:cNvPr id="18" name="TextBox 17"/>
           <p:cNvSpPr txBox="1"/>
           <p:nvPr/>
         </p:nvSpPr>
@@ -11279,7 +11039,7 @@
       </p:sp>
       <p:sp>
         <p:nvSpPr>
-          <p:cNvPr id="20" name="TextBox 19"/>
+          <p:cNvPr id="19" name="TextBox 18"/>
           <p:cNvSpPr txBox="1"/>
           <p:nvPr/>
         </p:nvSpPr>
@@ -11318,7 +11078,7 @@
       </p:sp>
       <p:sp>
         <p:nvSpPr>
-          <p:cNvPr id="21" name="TextBox 20"/>
+          <p:cNvPr id="20" name="TextBox 19"/>
           <p:cNvSpPr txBox="1"/>
           <p:nvPr/>
         </p:nvSpPr>
@@ -11357,7 +11117,7 @@
       </p:sp>
       <p:sp>
         <p:nvSpPr>
-          <p:cNvPr id="22" name="TextBox 21"/>
+          <p:cNvPr id="21" name="TextBox 20"/>
           <p:cNvSpPr txBox="1"/>
           <p:nvPr/>
         </p:nvSpPr>
@@ -11396,7 +11156,7 @@
       </p:sp>
       <p:sp>
         <p:nvSpPr>
-          <p:cNvPr id="23" name="TextBox 22"/>
+          <p:cNvPr id="22" name="TextBox 21"/>
           <p:cNvSpPr txBox="1"/>
           <p:nvPr/>
         </p:nvSpPr>
@@ -11435,7 +11195,7 @@
       </p:sp>
       <p:sp>
         <p:nvSpPr>
-          <p:cNvPr id="24" name="TextBox 23"/>
+          <p:cNvPr id="23" name="TextBox 22"/>
           <p:cNvSpPr txBox="1"/>
           <p:nvPr/>
         </p:nvSpPr>
@@ -11752,113 +11512,33 @@
           </a:p>
         </p:txBody>
       </p:sp>
-      <p:sp>
-        <p:nvSpPr>
-          <p:cNvPr id="8" name="Rounded Rectangle 7"/>
-          <p:cNvSpPr/>
-          <p:nvPr/>
-        </p:nvSpPr>
-        <p:spPr>
-          <a:xfrm>
-            <a:off x="640080" y="1645920"/>
-            <a:ext cx="5943600" cy="4572000"/>
-          </a:xfrm>
-          <a:prstGeom prst="roundRect">
-            <a:avLst>
-              <a:gd name="adj" fmla="val 2400"/>
-            </a:avLst>
-          </a:prstGeom>
-          <a:solidFill>
-            <a:srgbClr val="F8FAFC"/>
-          </a:solidFill>
-          <a:ln w="12700">
-            <a:solidFill>
-              <a:srgbClr val="64748B"/>
-            </a:solidFill>
-            <a:prstDash val="dash"/>
-          </a:ln>
-          <a:effectLst/>
-        </p:spPr>
-        <p:style>
-          <a:lnRef idx="1">
-            <a:schemeClr val="accent1"/>
-          </a:lnRef>
-          <a:fillRef idx="3">
-            <a:schemeClr val="accent1"/>
-          </a:fillRef>
-          <a:effectRef idx="2">
-            <a:schemeClr val="accent1"/>
-          </a:effectRef>
-          <a:fontRef idx="minor">
-            <a:schemeClr val="lt1"/>
-          </a:fontRef>
-        </p:style>
-        <p:txBody>
-          <a:bodyPr rtlCol="0" anchor="ctr"/>
-          <a:lstStyle/>
-          <a:p>
-            <a:pPr algn="ctr"/>
-          </a:p>
-        </p:txBody>
-      </p:sp>
-      <p:sp>
-        <p:nvSpPr>
-          <p:cNvPr id="9" name="TextBox 8"/>
-          <p:cNvSpPr txBox="1"/>
-          <p:nvPr/>
-        </p:nvSpPr>
-        <p:spPr>
-          <a:xfrm>
-            <a:off x="640080" y="1645920"/>
-            <a:ext cx="5943600" cy="4572000"/>
-          </a:xfrm>
-          <a:prstGeom prst="rect">
-            <a:avLst/>
-          </a:prstGeom>
-          <a:noFill/>
-        </p:spPr>
-        <p:txBody>
-          <a:bodyPr wrap="square" anchor="ctr" lIns="0" rIns="0" tIns="0" bIns="0">
-            <a:spAutoFit/>
-          </a:bodyPr>
-          <a:lstStyle/>
-          <a:p>
-            <a:pPr algn="ctr">
-              <a:lnSpc>
-                <a:spcPct val="110000"/>
-              </a:lnSpc>
-            </a:pPr>
-            <a:r>
-              <a:rPr sz="1600">
-                <a:solidFill>
-                  <a:srgbClr val="64748B"/>
-                </a:solidFill>
-                <a:latin typeface="Segoe UI"/>
-              </a:rPr>
-              <a:t>Diagram goes here</a:t>
-            </a:r>
-          </a:p>
-          <a:p>
-            <a:pPr algn="ctr">
-              <a:lnSpc>
-                <a:spcPct val="110000"/>
-              </a:lnSpc>
-            </a:pPr>
-            <a:r>
-              <a:rPr sz="1300">
-                <a:solidFill>
-                  <a:srgbClr val="64748B"/>
-                </a:solidFill>
-                <a:latin typeface="Consolas"/>
-              </a:rPr>
-              <a:t>report/diagrams/drawio/03_memory_rag.png</a:t>
-            </a:r>
-          </a:p>
-        </p:txBody>
-      </p:sp>
-      <p:sp>
-        <p:nvSpPr>
-          <p:cNvPr id="10" name="Rounded Rectangle 9"/>
+      <p:pic>
+        <p:nvPicPr>
+          <p:cNvPr id="8" name="Picture 7" descr="03_memory_rag.png"/>
+          <p:cNvPicPr>
+            <a:picLocks noChangeAspect="1"/>
+          </p:cNvPicPr>
+          <p:nvPr/>
+        </p:nvPicPr>
+        <p:blipFill>
+          <a:blip r:embed="rId2"/>
+          <a:stretch>
+            <a:fillRect/>
+          </a:stretch>
+        </p:blipFill>
+        <p:spPr>
+          <a:xfrm>
+            <a:off x="640080" y="1915341"/>
+            <a:ext cx="5943600" cy="4033157"/>
+          </a:xfrm>
+          <a:prstGeom prst="rect">
+            <a:avLst/>
+          </a:prstGeom>
+        </p:spPr>
+      </p:pic>
+      <p:sp>
+        <p:nvSpPr>
+          <p:cNvPr id="9" name="Rounded Rectangle 8"/>
           <p:cNvSpPr/>
           <p:nvPr/>
         </p:nvSpPr>
@@ -11904,7 +11584,7 @@
       </p:sp>
       <p:sp>
         <p:nvSpPr>
-          <p:cNvPr id="11" name="TextBox 10"/>
+          <p:cNvPr id="10" name="TextBox 9"/>
           <p:cNvSpPr txBox="1"/>
           <p:nvPr/>
         </p:nvSpPr>
@@ -11943,7 +11623,7 @@
       </p:sp>
       <p:sp>
         <p:nvSpPr>
-          <p:cNvPr id="12" name="TextBox 11"/>
+          <p:cNvPr id="11" name="TextBox 10"/>
           <p:cNvSpPr txBox="1"/>
           <p:nvPr/>
         </p:nvSpPr>
@@ -11982,7 +11662,7 @@
       </p:sp>
       <p:sp>
         <p:nvSpPr>
-          <p:cNvPr id="13" name="Rounded Rectangle 12"/>
+          <p:cNvPr id="12" name="Rounded Rectangle 11"/>
           <p:cNvSpPr/>
           <p:nvPr/>
         </p:nvSpPr>
@@ -12028,7 +11708,7 @@
       </p:sp>
       <p:sp>
         <p:nvSpPr>
-          <p:cNvPr id="14" name="TextBox 13"/>
+          <p:cNvPr id="13" name="TextBox 12"/>
           <p:cNvSpPr txBox="1"/>
           <p:nvPr/>
         </p:nvSpPr>
@@ -12067,7 +11747,7 @@
       </p:sp>
       <p:sp>
         <p:nvSpPr>
-          <p:cNvPr id="15" name="TextBox 14"/>
+          <p:cNvPr id="14" name="TextBox 13"/>
           <p:cNvSpPr txBox="1"/>
           <p:nvPr/>
         </p:nvSpPr>
@@ -12106,7 +11786,7 @@
       </p:sp>
       <p:sp>
         <p:nvSpPr>
-          <p:cNvPr id="16" name="Rounded Rectangle 15"/>
+          <p:cNvPr id="15" name="Rounded Rectangle 14"/>
           <p:cNvSpPr/>
           <p:nvPr/>
         </p:nvSpPr>
@@ -12152,7 +11832,7 @@
       </p:sp>
       <p:sp>
         <p:nvSpPr>
-          <p:cNvPr id="17" name="TextBox 16"/>
+          <p:cNvPr id="16" name="TextBox 15"/>
           <p:cNvSpPr txBox="1"/>
           <p:nvPr/>
         </p:nvSpPr>
@@ -12191,7 +11871,7 @@
       </p:sp>
       <p:sp>
         <p:nvSpPr>
-          <p:cNvPr id="18" name="TextBox 17"/>
+          <p:cNvPr id="17" name="TextBox 16"/>
           <p:cNvSpPr txBox="1"/>
           <p:nvPr/>
         </p:nvSpPr>
@@ -12230,7 +11910,7 @@
       </p:sp>
       <p:sp>
         <p:nvSpPr>
-          <p:cNvPr id="19" name="Rounded Rectangle 18"/>
+          <p:cNvPr id="18" name="Rounded Rectangle 17"/>
           <p:cNvSpPr/>
           <p:nvPr/>
         </p:nvSpPr>
@@ -12276,7 +11956,7 @@
       </p:sp>
       <p:sp>
         <p:nvSpPr>
-          <p:cNvPr id="20" name="TextBox 19"/>
+          <p:cNvPr id="19" name="TextBox 18"/>
           <p:cNvSpPr txBox="1"/>
           <p:nvPr/>
         </p:nvSpPr>
@@ -12315,7 +11995,7 @@
       </p:sp>
       <p:sp>
         <p:nvSpPr>
-          <p:cNvPr id="21" name="TextBox 20"/>
+          <p:cNvPr id="20" name="TextBox 19"/>
           <p:cNvSpPr txBox="1"/>
           <p:nvPr/>
         </p:nvSpPr>
@@ -12354,7 +12034,7 @@
       </p:sp>
       <p:sp>
         <p:nvSpPr>
-          <p:cNvPr id="22" name="TextBox 21"/>
+          <p:cNvPr id="21" name="TextBox 20"/>
           <p:cNvSpPr txBox="1"/>
           <p:nvPr/>
         </p:nvSpPr>
@@ -12393,7 +12073,7 @@
       </p:sp>
       <p:sp>
         <p:nvSpPr>
-          <p:cNvPr id="23" name="TextBox 22"/>
+          <p:cNvPr id="22" name="TextBox 21"/>
           <p:cNvSpPr txBox="1"/>
           <p:nvPr/>
         </p:nvSpPr>
@@ -12710,113 +12390,33 @@
           </a:p>
         </p:txBody>
       </p:sp>
-      <p:sp>
-        <p:nvSpPr>
-          <p:cNvPr id="8" name="Rounded Rectangle 7"/>
-          <p:cNvSpPr/>
-          <p:nvPr/>
-        </p:nvSpPr>
-        <p:spPr>
-          <a:xfrm>
-            <a:off x="640080" y="1691640"/>
-            <a:ext cx="6675120" cy="4526280"/>
-          </a:xfrm>
-          <a:prstGeom prst="roundRect">
-            <a:avLst>
-              <a:gd name="adj" fmla="val 2424"/>
-            </a:avLst>
-          </a:prstGeom>
-          <a:solidFill>
-            <a:srgbClr val="F8FAFC"/>
-          </a:solidFill>
-          <a:ln w="12700">
-            <a:solidFill>
-              <a:srgbClr val="64748B"/>
-            </a:solidFill>
-            <a:prstDash val="dash"/>
-          </a:ln>
-          <a:effectLst/>
-        </p:spPr>
-        <p:style>
-          <a:lnRef idx="1">
-            <a:schemeClr val="accent1"/>
-          </a:lnRef>
-          <a:fillRef idx="3">
-            <a:schemeClr val="accent1"/>
-          </a:fillRef>
-          <a:effectRef idx="2">
-            <a:schemeClr val="accent1"/>
-          </a:effectRef>
-          <a:fontRef idx="minor">
-            <a:schemeClr val="lt1"/>
-          </a:fontRef>
-        </p:style>
-        <p:txBody>
-          <a:bodyPr rtlCol="0" anchor="ctr"/>
-          <a:lstStyle/>
-          <a:p>
-            <a:pPr algn="ctr"/>
-          </a:p>
-        </p:txBody>
-      </p:sp>
-      <p:sp>
-        <p:nvSpPr>
-          <p:cNvPr id="9" name="TextBox 8"/>
-          <p:cNvSpPr txBox="1"/>
-          <p:nvPr/>
-        </p:nvSpPr>
-        <p:spPr>
-          <a:xfrm>
-            <a:off x="640080" y="1691640"/>
-            <a:ext cx="6675120" cy="4526280"/>
-          </a:xfrm>
-          <a:prstGeom prst="rect">
-            <a:avLst/>
-          </a:prstGeom>
-          <a:noFill/>
-        </p:spPr>
-        <p:txBody>
-          <a:bodyPr wrap="square" anchor="ctr" lIns="0" rIns="0" tIns="0" bIns="0">
-            <a:spAutoFit/>
-          </a:bodyPr>
-          <a:lstStyle/>
-          <a:p>
-            <a:pPr algn="ctr">
-              <a:lnSpc>
-                <a:spcPct val="110000"/>
-              </a:lnSpc>
-            </a:pPr>
-            <a:r>
-              <a:rPr sz="1600">
-                <a:solidFill>
-                  <a:srgbClr val="64748B"/>
-                </a:solidFill>
-                <a:latin typeface="Segoe UI"/>
-              </a:rPr>
-              <a:t>Diagram goes here</a:t>
-            </a:r>
-          </a:p>
-          <a:p>
-            <a:pPr algn="ctr">
-              <a:lnSpc>
-                <a:spcPct val="110000"/>
-              </a:lnSpc>
-            </a:pPr>
-            <a:r>
-              <a:rPr sz="1300">
-                <a:solidFill>
-                  <a:srgbClr val="64748B"/>
-                </a:solidFill>
-                <a:latin typeface="Consolas"/>
-              </a:rPr>
-              <a:t>report/diagrams/drawio/04_containment.png</a:t>
-            </a:r>
-          </a:p>
-        </p:txBody>
-      </p:sp>
-      <p:sp>
-        <p:nvSpPr>
-          <p:cNvPr id="10" name="Rounded Rectangle 9"/>
+      <p:pic>
+        <p:nvPicPr>
+          <p:cNvPr id="8" name="Picture 7" descr="04_containment.png"/>
+          <p:cNvPicPr>
+            <a:picLocks noChangeAspect="1"/>
+          </p:cNvPicPr>
+          <p:nvPr/>
+        </p:nvPicPr>
+        <p:blipFill>
+          <a:blip r:embed="rId2"/>
+          <a:stretch>
+            <a:fillRect/>
+          </a:stretch>
+        </p:blipFill>
+        <p:spPr>
+          <a:xfrm>
+            <a:off x="1217713" y="1691640"/>
+            <a:ext cx="5519853" cy="4526280"/>
+          </a:xfrm>
+          <a:prstGeom prst="rect">
+            <a:avLst/>
+          </a:prstGeom>
+        </p:spPr>
+      </p:pic>
+      <p:sp>
+        <p:nvSpPr>
+          <p:cNvPr id="9" name="Rounded Rectangle 8"/>
           <p:cNvSpPr/>
           <p:nvPr/>
         </p:nvSpPr>
@@ -12862,7 +12462,7 @@
       </p:sp>
       <p:sp>
         <p:nvSpPr>
-          <p:cNvPr id="11" name="TextBox 10"/>
+          <p:cNvPr id="10" name="TextBox 9"/>
           <p:cNvSpPr txBox="1"/>
           <p:nvPr/>
         </p:nvSpPr>
@@ -12901,7 +12501,7 @@
       </p:sp>
       <p:sp>
         <p:nvSpPr>
-          <p:cNvPr id="12" name="TextBox 11"/>
+          <p:cNvPr id="11" name="TextBox 10"/>
           <p:cNvSpPr txBox="1"/>
           <p:nvPr/>
         </p:nvSpPr>
@@ -12940,7 +12540,7 @@
       </p:sp>
       <p:sp>
         <p:nvSpPr>
-          <p:cNvPr id="13" name="Rounded Rectangle 12"/>
+          <p:cNvPr id="12" name="Rounded Rectangle 11"/>
           <p:cNvSpPr/>
           <p:nvPr/>
         </p:nvSpPr>
@@ -12986,7 +12586,7 @@
       </p:sp>
       <p:sp>
         <p:nvSpPr>
-          <p:cNvPr id="14" name="TextBox 13"/>
+          <p:cNvPr id="13" name="TextBox 12"/>
           <p:cNvSpPr txBox="1"/>
           <p:nvPr/>
         </p:nvSpPr>
@@ -13025,7 +12625,7 @@
       </p:sp>
       <p:sp>
         <p:nvSpPr>
-          <p:cNvPr id="15" name="TextBox 14"/>
+          <p:cNvPr id="14" name="TextBox 13"/>
           <p:cNvSpPr txBox="1"/>
           <p:nvPr/>
         </p:nvSpPr>
@@ -13064,7 +12664,7 @@
       </p:sp>
       <p:sp>
         <p:nvSpPr>
-          <p:cNvPr id="16" name="TextBox 15"/>
+          <p:cNvPr id="15" name="TextBox 14"/>
           <p:cNvSpPr txBox="1"/>
           <p:nvPr/>
         </p:nvSpPr>
@@ -13112,7 +12712,7 @@
       </p:sp>
       <p:sp>
         <p:nvSpPr>
-          <p:cNvPr id="17" name="TextBox 16"/>
+          <p:cNvPr id="16" name="TextBox 15"/>
           <p:cNvSpPr txBox="1"/>
           <p:nvPr/>
         </p:nvSpPr>
@@ -13151,7 +12751,7 @@
       </p:sp>
       <p:sp>
         <p:nvSpPr>
-          <p:cNvPr id="18" name="TextBox 17"/>
+          <p:cNvPr id="17" name="TextBox 16"/>
           <p:cNvSpPr txBox="1"/>
           <p:nvPr/>
         </p:nvSpPr>

</xml_diff>